<commit_message>
changes in 8, 9, 10
</commit_message>
<xml_diff>
--- a/8_amazon_bedrock/8_Amazon Bedrock.pptx
+++ b/8_amazon_bedrock/8_Amazon Bedrock.pptx
@@ -106,6 +106,11 @@
       </a:defRPr>
     </a:lvl9pPr>
   </p:defaultTextStyle>
+  <p:extLst>
+    <p:ext uri="{EFAFB233-063F-42B5-8137-9DF3F51BA10A}">
+      <p15:sldGuideLst xmlns:p15="http://schemas.microsoft.com/office/powerpoint/2012/main"/>
+    </p:ext>
+  </p:extLst>
 </p:presentation>
 </file>
 
@@ -258,7 +263,7 @@
           <a:p>
             <a:fld id="{F9A18E9F-2662-4AE1-980F-9099EC47A03E}" type="datetimeFigureOut">
               <a:rPr lang="en-GB" smtClean="0"/>
-              <a:t>28/10/2025</a:t>
+              <a:t>07/12/2025</a:t>
             </a:fld>
             <a:endParaRPr lang="en-GB"/>
           </a:p>
@@ -458,7 +463,7 @@
           <a:p>
             <a:fld id="{F9A18E9F-2662-4AE1-980F-9099EC47A03E}" type="datetimeFigureOut">
               <a:rPr lang="en-GB" smtClean="0"/>
-              <a:t>28/10/2025</a:t>
+              <a:t>07/12/2025</a:t>
             </a:fld>
             <a:endParaRPr lang="en-GB"/>
           </a:p>
@@ -668,7 +673,7 @@
           <a:p>
             <a:fld id="{F9A18E9F-2662-4AE1-980F-9099EC47A03E}" type="datetimeFigureOut">
               <a:rPr lang="en-GB" smtClean="0"/>
-              <a:t>28/10/2025</a:t>
+              <a:t>07/12/2025</a:t>
             </a:fld>
             <a:endParaRPr lang="en-GB"/>
           </a:p>
@@ -868,7 +873,7 @@
           <a:p>
             <a:fld id="{F9A18E9F-2662-4AE1-980F-9099EC47A03E}" type="datetimeFigureOut">
               <a:rPr lang="en-GB" smtClean="0"/>
-              <a:t>28/10/2025</a:t>
+              <a:t>07/12/2025</a:t>
             </a:fld>
             <a:endParaRPr lang="en-GB"/>
           </a:p>
@@ -1144,7 +1149,7 @@
           <a:p>
             <a:fld id="{F9A18E9F-2662-4AE1-980F-9099EC47A03E}" type="datetimeFigureOut">
               <a:rPr lang="en-GB" smtClean="0"/>
-              <a:t>28/10/2025</a:t>
+              <a:t>07/12/2025</a:t>
             </a:fld>
             <a:endParaRPr lang="en-GB"/>
           </a:p>
@@ -1412,7 +1417,7 @@
           <a:p>
             <a:fld id="{F9A18E9F-2662-4AE1-980F-9099EC47A03E}" type="datetimeFigureOut">
               <a:rPr lang="en-GB" smtClean="0"/>
-              <a:t>28/10/2025</a:t>
+              <a:t>07/12/2025</a:t>
             </a:fld>
             <a:endParaRPr lang="en-GB"/>
           </a:p>
@@ -1827,7 +1832,7 @@
           <a:p>
             <a:fld id="{F9A18E9F-2662-4AE1-980F-9099EC47A03E}" type="datetimeFigureOut">
               <a:rPr lang="en-GB" smtClean="0"/>
-              <a:t>28/10/2025</a:t>
+              <a:t>07/12/2025</a:t>
             </a:fld>
             <a:endParaRPr lang="en-GB"/>
           </a:p>
@@ -1969,7 +1974,7 @@
           <a:p>
             <a:fld id="{F9A18E9F-2662-4AE1-980F-9099EC47A03E}" type="datetimeFigureOut">
               <a:rPr lang="en-GB" smtClean="0"/>
-              <a:t>28/10/2025</a:t>
+              <a:t>07/12/2025</a:t>
             </a:fld>
             <a:endParaRPr lang="en-GB"/>
           </a:p>
@@ -2082,7 +2087,7 @@
           <a:p>
             <a:fld id="{F9A18E9F-2662-4AE1-980F-9099EC47A03E}" type="datetimeFigureOut">
               <a:rPr lang="en-GB" smtClean="0"/>
-              <a:t>28/10/2025</a:t>
+              <a:t>07/12/2025</a:t>
             </a:fld>
             <a:endParaRPr lang="en-GB"/>
           </a:p>
@@ -2395,7 +2400,7 @@
           <a:p>
             <a:fld id="{F9A18E9F-2662-4AE1-980F-9099EC47A03E}" type="datetimeFigureOut">
               <a:rPr lang="en-GB" smtClean="0"/>
-              <a:t>28/10/2025</a:t>
+              <a:t>07/12/2025</a:t>
             </a:fld>
             <a:endParaRPr lang="en-GB"/>
           </a:p>
@@ -2684,7 +2689,7 @@
           <a:p>
             <a:fld id="{F9A18E9F-2662-4AE1-980F-9099EC47A03E}" type="datetimeFigureOut">
               <a:rPr lang="en-GB" smtClean="0"/>
-              <a:t>28/10/2025</a:t>
+              <a:t>07/12/2025</a:t>
             </a:fld>
             <a:endParaRPr lang="en-GB"/>
           </a:p>
@@ -2927,7 +2932,7 @@
           <a:p>
             <a:fld id="{F9A18E9F-2662-4AE1-980F-9099EC47A03E}" type="datetimeFigureOut">
               <a:rPr lang="en-GB" smtClean="0"/>
-              <a:t>28/10/2025</a:t>
+              <a:t>07/12/2025</a:t>
             </a:fld>
             <a:endParaRPr lang="en-GB"/>
           </a:p>
@@ -3372,10 +3377,9 @@
           <a:lstStyle/>
           <a:p>
             <a:r>
-              <a:rPr lang="en-IN" dirty="0"/>
+              <a:rPr lang="en-IN" noProof="0" dirty="0"/>
               <a:t>8) Amazon Bedrock</a:t>
             </a:r>
-            <a:endParaRPr lang="en-GB" dirty="0"/>
           </a:p>
         </p:txBody>
       </p:sp>
@@ -3400,11 +3404,7 @@
           <a:bodyPr/>
           <a:lstStyle/>
           <a:p>
-            <a:r>
-              <a:rPr lang="en-IN"/>
-              <a:t>Atul Kahate</a:t>
-            </a:r>
-            <a:endParaRPr lang="en-GB"/>
+            <a:endParaRPr lang="en-IN" noProof="0" dirty="0"/>
           </a:p>
         </p:txBody>
       </p:sp>
@@ -3460,10 +3460,9 @@
           <a:lstStyle/>
           <a:p>
             <a:r>
-              <a:rPr lang="en-IN" dirty="0"/>
+              <a:rPr lang="en-IN" noProof="0" dirty="0"/>
               <a:t>Amazon Bedrock Basics</a:t>
             </a:r>
-            <a:endParaRPr lang="en-GB" dirty="0"/>
           </a:p>
         </p:txBody>
       </p:sp>
@@ -3489,35 +3488,35 @@
           <a:lstStyle/>
           <a:p>
             <a:r>
-              <a:rPr lang="en-US" b="1" dirty="0"/>
+              <a:rPr lang="en-IN" b="1" noProof="0" dirty="0"/>
               <a:t>Amazon Bedrock</a:t>
             </a:r>
             <a:r>
-              <a:rPr lang="en-US" dirty="0"/>
+              <a:rPr lang="en-IN" noProof="0" dirty="0"/>
               <a:t>: A fully managed serverless service by AWS that lets us build and scale generative AI apps without managing infrastructure</a:t>
             </a:r>
           </a:p>
           <a:p>
             <a:r>
-              <a:rPr lang="en-US" dirty="0"/>
+              <a:rPr lang="en-IN" noProof="0" dirty="0"/>
               <a:t>Provides API access to foundation models (FMs) from multiple providers (Anthropic, Cohere, Meta, Mistral, Amazon Titan, etc.)</a:t>
             </a:r>
           </a:p>
           <a:p>
             <a:pPr lvl="1"/>
             <a:r>
-              <a:rPr lang="en-US" dirty="0"/>
+              <a:rPr lang="en-IN" noProof="0" dirty="0"/>
               <a:t>Text, Chat, Embedding, Image</a:t>
             </a:r>
           </a:p>
           <a:p>
             <a:r>
-              <a:rPr lang="en-US" dirty="0"/>
+              <a:rPr lang="en-IN" noProof="0" dirty="0"/>
               <a:t>Steps</a:t>
             </a:r>
           </a:p>
           <a:p>
-            <a:endParaRPr lang="en-GB" dirty="0"/>
+            <a:endParaRPr lang="en-IN" noProof="0" dirty="0"/>
           </a:p>
         </p:txBody>
       </p:sp>
@@ -3568,10 +3567,9 @@
                     <a:lstStyle/>
                     <a:p>
                       <a:r>
-                        <a:rPr lang="en-IN" dirty="0"/>
+                        <a:rPr lang="en-IN" noProof="0" dirty="0"/>
                         <a:t>Step Number</a:t>
                       </a:r>
-                      <a:endParaRPr lang="en-GB" dirty="0"/>
                     </a:p>
                   </a:txBody>
                   <a:tcPr>
@@ -3619,10 +3617,9 @@
                     <a:lstStyle/>
                     <a:p>
                       <a:r>
-                        <a:rPr lang="en-IN" dirty="0"/>
+                        <a:rPr lang="en-IN" noProof="0" dirty="0"/>
                         <a:t>Details</a:t>
                       </a:r>
-                      <a:endParaRPr lang="en-GB" dirty="0"/>
                     </a:p>
                   </a:txBody>
                   <a:tcPr>
@@ -3677,10 +3674,9 @@
                     <a:lstStyle/>
                     <a:p>
                       <a:r>
-                        <a:rPr lang="en-IN" dirty="0"/>
+                        <a:rPr lang="en-IN" noProof="0" dirty="0"/>
                         <a:t>1</a:t>
                       </a:r>
-                      <a:endParaRPr lang="en-GB" dirty="0"/>
                     </a:p>
                   </a:txBody>
                   <a:tcPr>
@@ -3728,10 +3724,9 @@
                     <a:lstStyle/>
                     <a:p>
                       <a:r>
-                        <a:rPr lang="en-IN" dirty="0"/>
+                        <a:rPr lang="en-IN" noProof="0" dirty="0"/>
                         <a:t>Enable access to the required models in Amazon Bedrock</a:t>
                       </a:r>
-                      <a:endParaRPr lang="en-GB" dirty="0"/>
                     </a:p>
                   </a:txBody>
                   <a:tcPr>
@@ -3786,10 +3781,9 @@
                     <a:lstStyle/>
                     <a:p>
                       <a:r>
-                        <a:rPr lang="en-IN" dirty="0"/>
+                        <a:rPr lang="en-IN" noProof="0" dirty="0"/>
                         <a:t>2</a:t>
                       </a:r>
-                      <a:endParaRPr lang="en-GB" dirty="0"/>
                     </a:p>
                   </a:txBody>
                   <a:tcPr>
@@ -3837,10 +3831,9 @@
                     <a:lstStyle/>
                     <a:p>
                       <a:r>
-                        <a:rPr lang="en-IN" dirty="0"/>
+                        <a:rPr lang="en-IN" noProof="0" dirty="0"/>
                         <a:t>Create an IAM user with Administrator/Bedrock permissions and give CLI access, downloading the Access Key ID and Secret Access Key</a:t>
                       </a:r>
-                      <a:endParaRPr lang="en-GB" dirty="0"/>
                     </a:p>
                   </a:txBody>
                   <a:tcPr>
@@ -3895,10 +3888,9 @@
                     <a:lstStyle/>
                     <a:p>
                       <a:r>
-                        <a:rPr lang="en-IN" dirty="0"/>
+                        <a:rPr lang="en-IN" noProof="0" dirty="0"/>
                         <a:t>3</a:t>
                       </a:r>
-                      <a:endParaRPr lang="en-GB" dirty="0"/>
                     </a:p>
                   </a:txBody>
                   <a:tcPr>
@@ -3946,10 +3938,9 @@
                     <a:lstStyle/>
                     <a:p>
                       <a:r>
-                        <a:rPr lang="en-IN" dirty="0"/>
+                        <a:rPr lang="en-IN" noProof="0" dirty="0"/>
                         <a:t>Download and install AWS CLI on the local machine</a:t>
                       </a:r>
-                      <a:endParaRPr lang="en-GB" dirty="0"/>
                     </a:p>
                   </a:txBody>
                   <a:tcPr>
@@ -4004,10 +3995,9 @@
                     <a:lstStyle/>
                     <a:p>
                       <a:r>
-                        <a:rPr lang="en-IN" dirty="0"/>
+                        <a:rPr lang="en-IN" noProof="0" dirty="0"/>
                         <a:t>4</a:t>
                       </a:r>
-                      <a:endParaRPr lang="en-GB" dirty="0"/>
                     </a:p>
                   </a:txBody>
                   <a:tcPr>
@@ -4055,10 +4045,9 @@
                     <a:lstStyle/>
                     <a:p>
                       <a:r>
-                        <a:rPr lang="en-IN" dirty="0"/>
+                        <a:rPr lang="en-IN" noProof="0" dirty="0"/>
                         <a:t>Use Python boto3 API to connect to AWS Bedrock and execute code</a:t>
                       </a:r>
-                      <a:endParaRPr lang="en-GB" dirty="0"/>
                     </a:p>
                   </a:txBody>
                   <a:tcPr>
@@ -4163,9 +4152,9 @@
           <a:p>
             <a:r>
               <a:rPr lang="en-IN" dirty="0"/>
-              <a:t>Amazon Bedrock Code Examples</a:t>
-            </a:r>
-            <a:endParaRPr lang="en-GB" dirty="0"/>
+              <a:t>Directory: C:\code\agenticai\8_bedrock</a:t>
+            </a:r>
+            <a:endParaRPr lang="en-IN" noProof="0" dirty="0"/>
           </a:p>
         </p:txBody>
       </p:sp>
@@ -4190,11 +4179,7 @@
           <a:bodyPr/>
           <a:lstStyle/>
           <a:p>
-            <a:r>
-              <a:rPr lang="en-IN" dirty="0"/>
-              <a:t>Directory: C:\code\agenticai\8_bedrock</a:t>
-            </a:r>
-            <a:endParaRPr lang="en-GB" dirty="0"/>
+            <a:endParaRPr lang="en-IN" noProof="0" dirty="0"/>
           </a:p>
         </p:txBody>
       </p:sp>
@@ -4213,8 +4198,8 @@
           <p:nvPr/>
         </p:nvGraphicFramePr>
         <p:xfrm>
-          <a:off x="1082700" y="2492624"/>
-          <a:ext cx="8128000" cy="2225040"/>
+          <a:off x="838200" y="1501442"/>
+          <a:ext cx="10399846" cy="4988560"/>
         </p:xfrm>
         <a:graphic>
           <a:graphicData uri="http://schemas.openxmlformats.org/drawingml/2006/table">
@@ -4223,14 +4208,14 @@
                 <a:tableStyleId>{9DCAF9ED-07DC-4A11-8D7F-57B35C25682E}</a:tableStyleId>
               </a:tblPr>
               <a:tblGrid>
-                <a:gridCol w="2163071">
+                <a:gridCol w="3754740">
                   <a:extLst>
                     <a:ext uri="{9D8B030D-6E8A-4147-A177-3AD203B41FA5}">
                       <a16:colId xmlns:a16="http://schemas.microsoft.com/office/drawing/2014/main" val="4101946944"/>
                     </a:ext>
                   </a:extLst>
                 </a:gridCol>
-                <a:gridCol w="5964929">
+                <a:gridCol w="6645106">
                   <a:extLst>
                     <a:ext uri="{9D8B030D-6E8A-4147-A177-3AD203B41FA5}">
                       <a16:colId xmlns:a16="http://schemas.microsoft.com/office/drawing/2014/main" val="2015325017"/>
@@ -4245,10 +4230,9 @@
                     <a:lstStyle/>
                     <a:p>
                       <a:r>
-                        <a:rPr lang="en-IN" dirty="0"/>
-                        <a:t>Step Number</a:t>
+                        <a:rPr lang="en-IN" noProof="0" dirty="0"/>
+                        <a:t>File</a:t>
                       </a:r>
-                      <a:endParaRPr lang="en-GB" dirty="0"/>
                     </a:p>
                   </a:txBody>
                   <a:tcPr>
@@ -4296,10 +4280,9 @@
                     <a:lstStyle/>
                     <a:p>
                       <a:r>
-                        <a:rPr lang="en-IN" dirty="0"/>
+                        <a:rPr lang="en-IN" noProof="0" dirty="0"/>
                         <a:t>Details</a:t>
                       </a:r>
-                      <a:endParaRPr lang="en-GB" dirty="0"/>
                     </a:p>
                   </a:txBody>
                   <a:tcPr>
@@ -4354,7 +4337,7 @@
                     <a:lstStyle/>
                     <a:p>
                       <a:r>
-                        <a:rPr lang="en-GB" dirty="0"/>
+                        <a:rPr lang="en-IN" noProof="0" dirty="0"/>
                         <a:t>8_1_bedrock.py</a:t>
                       </a:r>
                     </a:p>
@@ -4404,10 +4387,9 @@
                     <a:lstStyle/>
                     <a:p>
                       <a:r>
-                        <a:rPr lang="en-IN" dirty="0"/>
+                        <a:rPr lang="en-IN" noProof="0" dirty="0"/>
                         <a:t>Send a request to Amazon Titan Text Lite model</a:t>
                       </a:r>
-                      <a:endParaRPr lang="en-GB" dirty="0"/>
                     </a:p>
                   </a:txBody>
                   <a:tcPr>
@@ -4479,7 +4461,7 @@
                         <a:defRPr/>
                       </a:pPr>
                       <a:r>
-                        <a:rPr lang="en-GB" dirty="0"/>
+                        <a:rPr lang="en-IN" noProof="0" dirty="0"/>
                         <a:t>8_2_bedrock.py</a:t>
                       </a:r>
                     </a:p>
@@ -4529,10 +4511,9 @@
                     <a:lstStyle/>
                     <a:p>
                       <a:r>
-                        <a:rPr lang="en-IN" dirty="0"/>
+                        <a:rPr lang="en-IN" noProof="0" dirty="0"/>
                         <a:t>Create a Chatbot</a:t>
                       </a:r>
-                      <a:endParaRPr lang="en-GB" dirty="0"/>
                     </a:p>
                   </a:txBody>
                   <a:tcPr>
@@ -4587,7 +4568,7 @@
                     <a:lstStyle/>
                     <a:p>
                       <a:r>
-                        <a:rPr lang="en-GB" dirty="0"/>
+                        <a:rPr lang="en-IN" noProof="0" dirty="0"/>
                         <a:t>8_3_bedrock.py</a:t>
                       </a:r>
                     </a:p>
@@ -4637,10 +4618,9 @@
                     <a:lstStyle/>
                     <a:p>
                       <a:r>
-                        <a:rPr lang="en-IN" dirty="0"/>
+                        <a:rPr lang="en-IN" noProof="0" dirty="0"/>
                         <a:t>Add memory to the Chatbot</a:t>
                       </a:r>
-                      <a:endParaRPr lang="en-GB" dirty="0"/>
                     </a:p>
                   </a:txBody>
                   <a:tcPr>
@@ -4695,10 +4675,9 @@
                     <a:lstStyle/>
                     <a:p>
                       <a:r>
-                        <a:rPr lang="en-IN" dirty="0"/>
+                        <a:rPr lang="en-IN" noProof="0" dirty="0"/>
                         <a:t>8_4_bedrock.py</a:t>
                       </a:r>
-                      <a:endParaRPr lang="en-GB" dirty="0"/>
                     </a:p>
                   </a:txBody>
                   <a:tcPr>
@@ -4746,10 +4725,9 @@
                     <a:lstStyle/>
                     <a:p>
                       <a:r>
-                        <a:rPr lang="en-IN" dirty="0"/>
+                        <a:rPr lang="en-IN" noProof="0" dirty="0"/>
                         <a:t>Add guardrails</a:t>
                       </a:r>
-                      <a:endParaRPr lang="en-GB" dirty="0"/>
                     </a:p>
                   </a:txBody>
                   <a:tcPr>
@@ -4804,10 +4782,9 @@
                     <a:lstStyle/>
                     <a:p>
                       <a:r>
-                        <a:rPr lang="en-IN" dirty="0"/>
+                        <a:rPr lang="en-IN" noProof="0" dirty="0"/>
                         <a:t>8_5_bedrock.py</a:t>
                       </a:r>
-                      <a:endParaRPr lang="en-GB" dirty="0"/>
                     </a:p>
                   </a:txBody>
                   <a:tcPr>
@@ -4855,10 +4832,9 @@
                     <a:lstStyle/>
                     <a:p>
                       <a:r>
-                        <a:rPr lang="en-IN" dirty="0"/>
+                        <a:rPr lang="en-IN" noProof="0" dirty="0"/>
                         <a:t>Stream the output</a:t>
                       </a:r>
-                      <a:endParaRPr lang="en-GB" dirty="0"/>
                     </a:p>
                   </a:txBody>
                   <a:tcPr>
@@ -4903,6 +4879,660 @@
                 <a:extLst>
                   <a:ext uri="{0D108BD9-81ED-4DB2-BD59-A6C34878D82A}">
                     <a16:rowId xmlns:a16="http://schemas.microsoft.com/office/drawing/2014/main" val="3068888724"/>
+                  </a:ext>
+                </a:extLst>
+              </a:tr>
+              <a:tr h="370840">
+                <a:tc>
+                  <a:txBody>
+                    <a:bodyPr/>
+                    <a:lstStyle/>
+                    <a:p>
+                      <a:r>
+                        <a:rPr lang="en-IN" noProof="0" dirty="0"/>
+                        <a:t>8_6_bedrock_image_stability.py</a:t>
+                      </a:r>
+                    </a:p>
+                  </a:txBody>
+                  <a:tcPr>
+                    <a:lnL w="12700" cap="flat" cmpd="sng" algn="ctr">
+                      <a:solidFill>
+                        <a:schemeClr val="tx1"/>
+                      </a:solidFill>
+                      <a:prstDash val="solid"/>
+                      <a:round/>
+                      <a:headEnd type="none" w="med" len="med"/>
+                      <a:tailEnd type="none" w="med" len="med"/>
+                    </a:lnL>
+                    <a:lnR w="12700" cap="flat" cmpd="sng" algn="ctr">
+                      <a:solidFill>
+                        <a:schemeClr val="tx1"/>
+                      </a:solidFill>
+                      <a:prstDash val="solid"/>
+                      <a:round/>
+                      <a:headEnd type="none" w="med" len="med"/>
+                      <a:tailEnd type="none" w="med" len="med"/>
+                    </a:lnR>
+                    <a:lnT w="12700" cap="flat" cmpd="sng" algn="ctr">
+                      <a:solidFill>
+                        <a:schemeClr val="tx1"/>
+                      </a:solidFill>
+                      <a:prstDash val="solid"/>
+                      <a:round/>
+                      <a:headEnd type="none" w="med" len="med"/>
+                      <a:tailEnd type="none" w="med" len="med"/>
+                    </a:lnT>
+                    <a:lnB w="12700" cap="flat" cmpd="sng" algn="ctr">
+                      <a:solidFill>
+                        <a:schemeClr val="tx1"/>
+                      </a:solidFill>
+                      <a:prstDash val="solid"/>
+                      <a:round/>
+                      <a:headEnd type="none" w="med" len="med"/>
+                      <a:tailEnd type="none" w="med" len="med"/>
+                    </a:lnB>
+                  </a:tcPr>
+                </a:tc>
+                <a:tc>
+                  <a:txBody>
+                    <a:bodyPr/>
+                    <a:lstStyle/>
+                    <a:p>
+                      <a:r>
+                        <a:rPr lang="en-IN" noProof="0" dirty="0"/>
+                        <a:t>Generate an image using the stability model</a:t>
+                      </a:r>
+                    </a:p>
+                  </a:txBody>
+                  <a:tcPr>
+                    <a:lnL w="12700" cap="flat" cmpd="sng" algn="ctr">
+                      <a:solidFill>
+                        <a:schemeClr val="tx1"/>
+                      </a:solidFill>
+                      <a:prstDash val="solid"/>
+                      <a:round/>
+                      <a:headEnd type="none" w="med" len="med"/>
+                      <a:tailEnd type="none" w="med" len="med"/>
+                    </a:lnL>
+                    <a:lnR w="12700" cap="flat" cmpd="sng" algn="ctr">
+                      <a:solidFill>
+                        <a:schemeClr val="tx1"/>
+                      </a:solidFill>
+                      <a:prstDash val="solid"/>
+                      <a:round/>
+                      <a:headEnd type="none" w="med" len="med"/>
+                      <a:tailEnd type="none" w="med" len="med"/>
+                    </a:lnR>
+                    <a:lnT w="12700" cap="flat" cmpd="sng" algn="ctr">
+                      <a:solidFill>
+                        <a:schemeClr val="tx1"/>
+                      </a:solidFill>
+                      <a:prstDash val="solid"/>
+                      <a:round/>
+                      <a:headEnd type="none" w="med" len="med"/>
+                      <a:tailEnd type="none" w="med" len="med"/>
+                    </a:lnT>
+                    <a:lnB w="12700" cap="flat" cmpd="sng" algn="ctr">
+                      <a:solidFill>
+                        <a:schemeClr val="tx1"/>
+                      </a:solidFill>
+                      <a:prstDash val="solid"/>
+                      <a:round/>
+                      <a:headEnd type="none" w="med" len="med"/>
+                      <a:tailEnd type="none" w="med" len="med"/>
+                    </a:lnB>
+                  </a:tcPr>
+                </a:tc>
+                <a:extLst>
+                  <a:ext uri="{0D108BD9-81ED-4DB2-BD59-A6C34878D82A}">
+                    <a16:rowId xmlns:a16="http://schemas.microsoft.com/office/drawing/2014/main" val="3551855905"/>
+                  </a:ext>
+                </a:extLst>
+              </a:tr>
+              <a:tr h="370840">
+                <a:tc>
+                  <a:txBody>
+                    <a:bodyPr/>
+                    <a:lstStyle/>
+                    <a:p>
+                      <a:r>
+                        <a:rPr lang="en-IN" noProof="0" dirty="0"/>
+                        <a:t>8_7_bedrock_image_titan.py</a:t>
+                      </a:r>
+                    </a:p>
+                  </a:txBody>
+                  <a:tcPr>
+                    <a:lnL w="12700" cap="flat" cmpd="sng" algn="ctr">
+                      <a:solidFill>
+                        <a:schemeClr val="tx1"/>
+                      </a:solidFill>
+                      <a:prstDash val="solid"/>
+                      <a:round/>
+                      <a:headEnd type="none" w="med" len="med"/>
+                      <a:tailEnd type="none" w="med" len="med"/>
+                    </a:lnL>
+                    <a:lnR w="12700" cap="flat" cmpd="sng" algn="ctr">
+                      <a:solidFill>
+                        <a:schemeClr val="tx1"/>
+                      </a:solidFill>
+                      <a:prstDash val="solid"/>
+                      <a:round/>
+                      <a:headEnd type="none" w="med" len="med"/>
+                      <a:tailEnd type="none" w="med" len="med"/>
+                    </a:lnR>
+                    <a:lnT w="12700" cap="flat" cmpd="sng" algn="ctr">
+                      <a:solidFill>
+                        <a:schemeClr val="tx1"/>
+                      </a:solidFill>
+                      <a:prstDash val="solid"/>
+                      <a:round/>
+                      <a:headEnd type="none" w="med" len="med"/>
+                      <a:tailEnd type="none" w="med" len="med"/>
+                    </a:lnT>
+                    <a:lnB w="12700" cap="flat" cmpd="sng" algn="ctr">
+                      <a:solidFill>
+                        <a:schemeClr val="tx1"/>
+                      </a:solidFill>
+                      <a:prstDash val="solid"/>
+                      <a:round/>
+                      <a:headEnd type="none" w="med" len="med"/>
+                      <a:tailEnd type="none" w="med" len="med"/>
+                    </a:lnB>
+                  </a:tcPr>
+                </a:tc>
+                <a:tc>
+                  <a:txBody>
+                    <a:bodyPr/>
+                    <a:lstStyle/>
+                    <a:p>
+                      <a:r>
+                        <a:rPr lang="en-IN" noProof="0" dirty="0"/>
+                        <a:t>Generate an image using the Amazon titan model</a:t>
+                      </a:r>
+                    </a:p>
+                  </a:txBody>
+                  <a:tcPr>
+                    <a:lnL w="12700" cap="flat" cmpd="sng" algn="ctr">
+                      <a:solidFill>
+                        <a:schemeClr val="tx1"/>
+                      </a:solidFill>
+                      <a:prstDash val="solid"/>
+                      <a:round/>
+                      <a:headEnd type="none" w="med" len="med"/>
+                      <a:tailEnd type="none" w="med" len="med"/>
+                    </a:lnL>
+                    <a:lnR w="12700" cap="flat" cmpd="sng" algn="ctr">
+                      <a:solidFill>
+                        <a:schemeClr val="tx1"/>
+                      </a:solidFill>
+                      <a:prstDash val="solid"/>
+                      <a:round/>
+                      <a:headEnd type="none" w="med" len="med"/>
+                      <a:tailEnd type="none" w="med" len="med"/>
+                    </a:lnR>
+                    <a:lnT w="12700" cap="flat" cmpd="sng" algn="ctr">
+                      <a:solidFill>
+                        <a:schemeClr val="tx1"/>
+                      </a:solidFill>
+                      <a:prstDash val="solid"/>
+                      <a:round/>
+                      <a:headEnd type="none" w="med" len="med"/>
+                      <a:tailEnd type="none" w="med" len="med"/>
+                    </a:lnT>
+                    <a:lnB w="12700" cap="flat" cmpd="sng" algn="ctr">
+                      <a:solidFill>
+                        <a:schemeClr val="tx1"/>
+                      </a:solidFill>
+                      <a:prstDash val="solid"/>
+                      <a:round/>
+                      <a:headEnd type="none" w="med" len="med"/>
+                      <a:tailEnd type="none" w="med" len="med"/>
+                    </a:lnB>
+                  </a:tcPr>
+                </a:tc>
+                <a:extLst>
+                  <a:ext uri="{0D108BD9-81ED-4DB2-BD59-A6C34878D82A}">
+                    <a16:rowId xmlns:a16="http://schemas.microsoft.com/office/drawing/2014/main" val="1537212961"/>
+                  </a:ext>
+                </a:extLst>
+              </a:tr>
+              <a:tr h="370840">
+                <a:tc>
+                  <a:txBody>
+                    <a:bodyPr/>
+                    <a:lstStyle/>
+                    <a:p>
+                      <a:r>
+                        <a:rPr lang="en-IN" noProof="0" dirty="0"/>
+                        <a:t>8_8_bedrock_text_embedding.py</a:t>
+                      </a:r>
+                    </a:p>
+                  </a:txBody>
+                  <a:tcPr>
+                    <a:lnL w="12700" cap="flat" cmpd="sng" algn="ctr">
+                      <a:solidFill>
+                        <a:schemeClr val="tx1"/>
+                      </a:solidFill>
+                      <a:prstDash val="solid"/>
+                      <a:round/>
+                      <a:headEnd type="none" w="med" len="med"/>
+                      <a:tailEnd type="none" w="med" len="med"/>
+                    </a:lnL>
+                    <a:lnR w="12700" cap="flat" cmpd="sng" algn="ctr">
+                      <a:solidFill>
+                        <a:schemeClr val="tx1"/>
+                      </a:solidFill>
+                      <a:prstDash val="solid"/>
+                      <a:round/>
+                      <a:headEnd type="none" w="med" len="med"/>
+                      <a:tailEnd type="none" w="med" len="med"/>
+                    </a:lnR>
+                    <a:lnT w="12700" cap="flat" cmpd="sng" algn="ctr">
+                      <a:solidFill>
+                        <a:schemeClr val="tx1"/>
+                      </a:solidFill>
+                      <a:prstDash val="solid"/>
+                      <a:round/>
+                      <a:headEnd type="none" w="med" len="med"/>
+                      <a:tailEnd type="none" w="med" len="med"/>
+                    </a:lnT>
+                    <a:lnB w="12700" cap="flat" cmpd="sng" algn="ctr">
+                      <a:solidFill>
+                        <a:schemeClr val="tx1"/>
+                      </a:solidFill>
+                      <a:prstDash val="solid"/>
+                      <a:round/>
+                      <a:headEnd type="none" w="med" len="med"/>
+                      <a:tailEnd type="none" w="med" len="med"/>
+                    </a:lnB>
+                  </a:tcPr>
+                </a:tc>
+                <a:tc>
+                  <a:txBody>
+                    <a:bodyPr/>
+                    <a:lstStyle/>
+                    <a:p>
+                      <a:r>
+                        <a:rPr lang="en-IN" noProof="0" dirty="0"/>
+                        <a:t>Create and compare text embeddings using Amazon embedding model</a:t>
+                      </a:r>
+                    </a:p>
+                  </a:txBody>
+                  <a:tcPr>
+                    <a:lnL w="12700" cap="flat" cmpd="sng" algn="ctr">
+                      <a:solidFill>
+                        <a:schemeClr val="tx1"/>
+                      </a:solidFill>
+                      <a:prstDash val="solid"/>
+                      <a:round/>
+                      <a:headEnd type="none" w="med" len="med"/>
+                      <a:tailEnd type="none" w="med" len="med"/>
+                    </a:lnL>
+                    <a:lnR w="12700" cap="flat" cmpd="sng" algn="ctr">
+                      <a:solidFill>
+                        <a:schemeClr val="tx1"/>
+                      </a:solidFill>
+                      <a:prstDash val="solid"/>
+                      <a:round/>
+                      <a:headEnd type="none" w="med" len="med"/>
+                      <a:tailEnd type="none" w="med" len="med"/>
+                    </a:lnR>
+                    <a:lnT w="12700" cap="flat" cmpd="sng" algn="ctr">
+                      <a:solidFill>
+                        <a:schemeClr val="tx1"/>
+                      </a:solidFill>
+                      <a:prstDash val="solid"/>
+                      <a:round/>
+                      <a:headEnd type="none" w="med" len="med"/>
+                      <a:tailEnd type="none" w="med" len="med"/>
+                    </a:lnT>
+                    <a:lnB w="12700" cap="flat" cmpd="sng" algn="ctr">
+                      <a:solidFill>
+                        <a:schemeClr val="tx1"/>
+                      </a:solidFill>
+                      <a:prstDash val="solid"/>
+                      <a:round/>
+                      <a:headEnd type="none" w="med" len="med"/>
+                      <a:tailEnd type="none" w="med" len="med"/>
+                    </a:lnB>
+                  </a:tcPr>
+                </a:tc>
+                <a:extLst>
+                  <a:ext uri="{0D108BD9-81ED-4DB2-BD59-A6C34878D82A}">
+                    <a16:rowId xmlns:a16="http://schemas.microsoft.com/office/drawing/2014/main" val="3953518771"/>
+                  </a:ext>
+                </a:extLst>
+              </a:tr>
+              <a:tr h="370840">
+                <a:tc>
+                  <a:txBody>
+                    <a:bodyPr/>
+                    <a:lstStyle/>
+                    <a:p>
+                      <a:r>
+                        <a:rPr lang="en-IN" noProof="0" dirty="0"/>
+                        <a:t>8_9_bedrock_image_embedding.py</a:t>
+                      </a:r>
+                    </a:p>
+                  </a:txBody>
+                  <a:tcPr>
+                    <a:lnL w="12700" cap="flat" cmpd="sng" algn="ctr">
+                      <a:solidFill>
+                        <a:schemeClr val="tx1"/>
+                      </a:solidFill>
+                      <a:prstDash val="solid"/>
+                      <a:round/>
+                      <a:headEnd type="none" w="med" len="med"/>
+                      <a:tailEnd type="none" w="med" len="med"/>
+                    </a:lnL>
+                    <a:lnR w="12700" cap="flat" cmpd="sng" algn="ctr">
+                      <a:solidFill>
+                        <a:schemeClr val="tx1"/>
+                      </a:solidFill>
+                      <a:prstDash val="solid"/>
+                      <a:round/>
+                      <a:headEnd type="none" w="med" len="med"/>
+                      <a:tailEnd type="none" w="med" len="med"/>
+                    </a:lnR>
+                    <a:lnT w="12700" cap="flat" cmpd="sng" algn="ctr">
+                      <a:solidFill>
+                        <a:schemeClr val="tx1"/>
+                      </a:solidFill>
+                      <a:prstDash val="solid"/>
+                      <a:round/>
+                      <a:headEnd type="none" w="med" len="med"/>
+                      <a:tailEnd type="none" w="med" len="med"/>
+                    </a:lnT>
+                    <a:lnB w="12700" cap="flat" cmpd="sng" algn="ctr">
+                      <a:solidFill>
+                        <a:schemeClr val="tx1"/>
+                      </a:solidFill>
+                      <a:prstDash val="solid"/>
+                      <a:round/>
+                      <a:headEnd type="none" w="med" len="med"/>
+                      <a:tailEnd type="none" w="med" len="med"/>
+                    </a:lnB>
+                  </a:tcPr>
+                </a:tc>
+                <a:tc>
+                  <a:txBody>
+                    <a:bodyPr/>
+                    <a:lstStyle/>
+                    <a:p>
+                      <a:r>
+                        <a:rPr lang="en-IN" noProof="0" dirty="0"/>
+                        <a:t>Create and compare image embeddings using Amazon embedding model</a:t>
+                      </a:r>
+                    </a:p>
+                  </a:txBody>
+                  <a:tcPr>
+                    <a:lnL w="12700" cap="flat" cmpd="sng" algn="ctr">
+                      <a:solidFill>
+                        <a:schemeClr val="tx1"/>
+                      </a:solidFill>
+                      <a:prstDash val="solid"/>
+                      <a:round/>
+                      <a:headEnd type="none" w="med" len="med"/>
+                      <a:tailEnd type="none" w="med" len="med"/>
+                    </a:lnL>
+                    <a:lnR w="12700" cap="flat" cmpd="sng" algn="ctr">
+                      <a:solidFill>
+                        <a:schemeClr val="tx1"/>
+                      </a:solidFill>
+                      <a:prstDash val="solid"/>
+                      <a:round/>
+                      <a:headEnd type="none" w="med" len="med"/>
+                      <a:tailEnd type="none" w="med" len="med"/>
+                    </a:lnR>
+                    <a:lnT w="12700" cap="flat" cmpd="sng" algn="ctr">
+                      <a:solidFill>
+                        <a:schemeClr val="tx1"/>
+                      </a:solidFill>
+                      <a:prstDash val="solid"/>
+                      <a:round/>
+                      <a:headEnd type="none" w="med" len="med"/>
+                      <a:tailEnd type="none" w="med" len="med"/>
+                    </a:lnT>
+                    <a:lnB w="12700" cap="flat" cmpd="sng" algn="ctr">
+                      <a:solidFill>
+                        <a:schemeClr val="tx1"/>
+                      </a:solidFill>
+                      <a:prstDash val="solid"/>
+                      <a:round/>
+                      <a:headEnd type="none" w="med" len="med"/>
+                      <a:tailEnd type="none" w="med" len="med"/>
+                    </a:lnB>
+                  </a:tcPr>
+                </a:tc>
+                <a:extLst>
+                  <a:ext uri="{0D108BD9-81ED-4DB2-BD59-A6C34878D82A}">
+                    <a16:rowId xmlns:a16="http://schemas.microsoft.com/office/drawing/2014/main" val="1659546713"/>
+                  </a:ext>
+                </a:extLst>
+              </a:tr>
+              <a:tr h="370840">
+                <a:tc>
+                  <a:txBody>
+                    <a:bodyPr/>
+                    <a:lstStyle/>
+                    <a:p>
+                      <a:r>
+                        <a:rPr lang="en-IN" noProof="0" dirty="0"/>
+                        <a:t>8_10_bedrock_langchain_basic.py</a:t>
+                      </a:r>
+                    </a:p>
+                  </a:txBody>
+                  <a:tcPr>
+                    <a:lnL w="12700" cap="flat" cmpd="sng" algn="ctr">
+                      <a:solidFill>
+                        <a:schemeClr val="tx1"/>
+                      </a:solidFill>
+                      <a:prstDash val="solid"/>
+                      <a:round/>
+                      <a:headEnd type="none" w="med" len="med"/>
+                      <a:tailEnd type="none" w="med" len="med"/>
+                    </a:lnL>
+                    <a:lnR w="12700" cap="flat" cmpd="sng" algn="ctr">
+                      <a:solidFill>
+                        <a:schemeClr val="tx1"/>
+                      </a:solidFill>
+                      <a:prstDash val="solid"/>
+                      <a:round/>
+                      <a:headEnd type="none" w="med" len="med"/>
+                      <a:tailEnd type="none" w="med" len="med"/>
+                    </a:lnR>
+                    <a:lnT w="12700" cap="flat" cmpd="sng" algn="ctr">
+                      <a:solidFill>
+                        <a:schemeClr val="tx1"/>
+                      </a:solidFill>
+                      <a:prstDash val="solid"/>
+                      <a:round/>
+                      <a:headEnd type="none" w="med" len="med"/>
+                      <a:tailEnd type="none" w="med" len="med"/>
+                    </a:lnT>
+                    <a:lnB w="12700" cap="flat" cmpd="sng" algn="ctr">
+                      <a:solidFill>
+                        <a:schemeClr val="tx1"/>
+                      </a:solidFill>
+                      <a:prstDash val="solid"/>
+                      <a:round/>
+                      <a:headEnd type="none" w="med" len="med"/>
+                      <a:tailEnd type="none" w="med" len="med"/>
+                    </a:lnB>
+                  </a:tcPr>
+                </a:tc>
+                <a:tc>
+                  <a:txBody>
+                    <a:bodyPr/>
+                    <a:lstStyle/>
+                    <a:p>
+                      <a:r>
+                        <a:rPr lang="en-IN" noProof="0" dirty="0"/>
+                        <a:t>Integrating </a:t>
+                      </a:r>
+                      <a:r>
+                        <a:rPr lang="en-IN" noProof="0" dirty="0" err="1"/>
+                        <a:t>Langchain</a:t>
+                      </a:r>
+                      <a:r>
+                        <a:rPr lang="en-IN" noProof="0" dirty="0"/>
+                        <a:t> with Bedrock</a:t>
+                      </a:r>
+                    </a:p>
+                  </a:txBody>
+                  <a:tcPr>
+                    <a:lnL w="12700" cap="flat" cmpd="sng" algn="ctr">
+                      <a:solidFill>
+                        <a:schemeClr val="tx1"/>
+                      </a:solidFill>
+                      <a:prstDash val="solid"/>
+                      <a:round/>
+                      <a:headEnd type="none" w="med" len="med"/>
+                      <a:tailEnd type="none" w="med" len="med"/>
+                    </a:lnL>
+                    <a:lnR w="12700" cap="flat" cmpd="sng" algn="ctr">
+                      <a:solidFill>
+                        <a:schemeClr val="tx1"/>
+                      </a:solidFill>
+                      <a:prstDash val="solid"/>
+                      <a:round/>
+                      <a:headEnd type="none" w="med" len="med"/>
+                      <a:tailEnd type="none" w="med" len="med"/>
+                    </a:lnR>
+                    <a:lnT w="12700" cap="flat" cmpd="sng" algn="ctr">
+                      <a:solidFill>
+                        <a:schemeClr val="tx1"/>
+                      </a:solidFill>
+                      <a:prstDash val="solid"/>
+                      <a:round/>
+                      <a:headEnd type="none" w="med" len="med"/>
+                      <a:tailEnd type="none" w="med" len="med"/>
+                    </a:lnT>
+                    <a:lnB w="12700" cap="flat" cmpd="sng" algn="ctr">
+                      <a:solidFill>
+                        <a:schemeClr val="tx1"/>
+                      </a:solidFill>
+                      <a:prstDash val="solid"/>
+                      <a:round/>
+                      <a:headEnd type="none" w="med" len="med"/>
+                      <a:tailEnd type="none" w="med" len="med"/>
+                    </a:lnB>
+                  </a:tcPr>
+                </a:tc>
+                <a:extLst>
+                  <a:ext uri="{0D108BD9-81ED-4DB2-BD59-A6C34878D82A}">
+                    <a16:rowId xmlns:a16="http://schemas.microsoft.com/office/drawing/2014/main" val="3057928721"/>
+                  </a:ext>
+                </a:extLst>
+              </a:tr>
+              <a:tr h="370840">
+                <a:tc>
+                  <a:txBody>
+                    <a:bodyPr/>
+                    <a:lstStyle/>
+                    <a:p>
+                      <a:r>
+                        <a:rPr lang="en-IN" noProof="0" dirty="0"/>
+                        <a:t>8_11_bedrock_langchain_rag.py</a:t>
+                      </a:r>
+                    </a:p>
+                  </a:txBody>
+                  <a:tcPr>
+                    <a:lnL w="12700" cap="flat" cmpd="sng" algn="ctr">
+                      <a:solidFill>
+                        <a:schemeClr val="tx1"/>
+                      </a:solidFill>
+                      <a:prstDash val="solid"/>
+                      <a:round/>
+                      <a:headEnd type="none" w="med" len="med"/>
+                      <a:tailEnd type="none" w="med" len="med"/>
+                    </a:lnL>
+                    <a:lnR w="12700" cap="flat" cmpd="sng" algn="ctr">
+                      <a:solidFill>
+                        <a:schemeClr val="tx1"/>
+                      </a:solidFill>
+                      <a:prstDash val="solid"/>
+                      <a:round/>
+                      <a:headEnd type="none" w="med" len="med"/>
+                      <a:tailEnd type="none" w="med" len="med"/>
+                    </a:lnR>
+                    <a:lnT w="12700" cap="flat" cmpd="sng" algn="ctr">
+                      <a:solidFill>
+                        <a:schemeClr val="tx1"/>
+                      </a:solidFill>
+                      <a:prstDash val="solid"/>
+                      <a:round/>
+                      <a:headEnd type="none" w="med" len="med"/>
+                      <a:tailEnd type="none" w="med" len="med"/>
+                    </a:lnT>
+                    <a:lnB w="12700" cap="flat" cmpd="sng" algn="ctr">
+                      <a:solidFill>
+                        <a:schemeClr val="tx1"/>
+                      </a:solidFill>
+                      <a:prstDash val="solid"/>
+                      <a:round/>
+                      <a:headEnd type="none" w="med" len="med"/>
+                      <a:tailEnd type="none" w="med" len="med"/>
+                    </a:lnB>
+                  </a:tcPr>
+                </a:tc>
+                <a:tc>
+                  <a:txBody>
+                    <a:bodyPr/>
+                    <a:lstStyle/>
+                    <a:p>
+                      <a:r>
+                        <a:rPr lang="en-IN" noProof="0" dirty="0" err="1"/>
+                        <a:t>Langchain</a:t>
+                      </a:r>
+                      <a:r>
+                        <a:rPr lang="en-IN" noProof="0" dirty="0"/>
+                        <a:t> + Bedrock + Basic RAG</a:t>
+                      </a:r>
+                    </a:p>
+                  </a:txBody>
+                  <a:tcPr>
+                    <a:lnL w="12700" cap="flat" cmpd="sng" algn="ctr">
+                      <a:solidFill>
+                        <a:schemeClr val="tx1"/>
+                      </a:solidFill>
+                      <a:prstDash val="solid"/>
+                      <a:round/>
+                      <a:headEnd type="none" w="med" len="med"/>
+                      <a:tailEnd type="none" w="med" len="med"/>
+                    </a:lnL>
+                    <a:lnR w="12700" cap="flat" cmpd="sng" algn="ctr">
+                      <a:solidFill>
+                        <a:schemeClr val="tx1"/>
+                      </a:solidFill>
+                      <a:prstDash val="solid"/>
+                      <a:round/>
+                      <a:headEnd type="none" w="med" len="med"/>
+                      <a:tailEnd type="none" w="med" len="med"/>
+                    </a:lnR>
+                    <a:lnT w="12700" cap="flat" cmpd="sng" algn="ctr">
+                      <a:solidFill>
+                        <a:schemeClr val="tx1"/>
+                      </a:solidFill>
+                      <a:prstDash val="solid"/>
+                      <a:round/>
+                      <a:headEnd type="none" w="med" len="med"/>
+                      <a:tailEnd type="none" w="med" len="med"/>
+                    </a:lnT>
+                    <a:lnB w="12700" cap="flat" cmpd="sng" algn="ctr">
+                      <a:solidFill>
+                        <a:schemeClr val="tx1"/>
+                      </a:solidFill>
+                      <a:prstDash val="solid"/>
+                      <a:round/>
+                      <a:headEnd type="none" w="med" len="med"/>
+                      <a:tailEnd type="none" w="med" len="med"/>
+                    </a:lnB>
+                  </a:tcPr>
+                </a:tc>
+                <a:extLst>
+                  <a:ext uri="{0D108BD9-81ED-4DB2-BD59-A6C34878D82A}">
+                    <a16:rowId xmlns:a16="http://schemas.microsoft.com/office/drawing/2014/main" val="1061492844"/>
                   </a:ext>
                 </a:extLst>
               </a:tr>

</xml_diff>